<commit_message>
innovatex-t3-coastal-plastic: trained detector numbers rendered (test mAP50 0.857 vs zero-shot 0.394; cross-site 0.524), flux limit, rebuild
</commit_message>
<xml_diff>
--- a/innovatex-t3-coastal-plastic/deliverables/zonal-deck.pptx
+++ b/innovatex-t3-coastal-plastic/deliverables/zonal-deck.pptx
@@ -19,9 +19,10 @@
     <p:sldId id="267" r:id="rId13"/>
     <p:sldId id="268" r:id="rId14"/>
     <p:sldId id="269" r:id="rId15"/>
+    <p:sldId id="270" r:id="rId16"/>
   </p:sldIdLst>
   <p:notesMasterIdLst>
-    <p:notesMasterId r:id="rId16"/>
+    <p:notesMasterId r:id="rId17"/>
   </p:notesMasterIdLst>
   <p:sldSz cx="12192000" cy="6858000"/>
   <p:notesSz cx="6858000" cy="12192000"/>
@@ -515,9 +516,9 @@
           <a:p>
             <a:r>
               <a:rPr lang="en-US" dirty="0"/>
-              <a:t>TIME 0:00–0:30 (30 s). LOGISTICS: present zonal-deck.pdf from your own laptop; the dashboard open in a second tab (bash deliverables/serve_dashboard.sh, then http://localhost:8765); it runs offline except the map tiles.
-SAY: "We're ‹team›. Our problem is one specific leak: floating single-use packaging escaping through Mumbai's small storm-water outfalls. Mumbai already has trash booms; we make them work harder and make their numbers trustworthy."
-LINE TO LAND: "We don't propose another barrier. We make the city's existing barriers accountable."
+              <a:t>TIME 0:00–0:25 (25 s). LOGISTICS: present zonal-deck.pdf from your own laptop; the dashboard open in a second tab (bash deliverables/serve_dashboard.sh, then http://localhost:8765); it runs offline except the map tiles.
+SAY: "We're ‹team›. We picked one leak: floating single-use packaging escaping through Mumbai's storm-water outfalls. Mumbai already runs trash booms. We propose to make them measurable and better timed, and to test a retrofit that keeps more of what they catch."
+LINE TO LAND: "Not another barrier: a way to make the city's existing barriers accountable."
 DON'T SAY "we built a prototype". The software is built; the hardware is PLANNED.</a:t>
             </a:r>
             <a:endParaRPr lang="en-US" dirty="0"/>
@@ -606,9 +607,9 @@
           <a:p>
             <a:r>
               <a:rPr lang="en-US" dirty="0"/>
-              <a:t>TIME 8:40–9:15 (35 s).
-SAY: "The money exists: BMC already pays for booms and their upkeep. We ask for one ward and three outfalls to prove it."
-LINE TO LAND: "Two Interceptors cover two creeks. Give us three small outfalls, and we'll show the city's booms can be measured, timed and trusted."
+              <a:t>TIME 8:20–9:15 (55 s).
+SAY: "By December we commit to a working closed loop on the bench: tow tank, sensor node, twin and records. With permission, our first field site would be one existing BMC boom. We ask for one site survey and one conversation with the storm-water drain department."
+LINE TO LAND: "Give us one existing boom to measure, and we'll show whether timing, a better pocket and honest records move the numbers."
 RESERVE 45 s for overrun.</a:t>
             </a:r>
             <a:endParaRPr lang="en-US" dirty="0"/>
@@ -961,7 +962,7 @@
           <a:p>
             <a:r>
               <a:rPr lang="en-US" dirty="0"/>
-              <a:t>Point judges to the repo files if they ask for evidence.</a:t>
+              <a:t>Use for "how well do you know Mumbai?"</a:t>
             </a:r>
             <a:endParaRPr lang="en-US" dirty="0"/>
           </a:p>
@@ -1003,6 +1004,94 @@
 </p:notes>
 </file>
 
+<file path=ppt/notesSlides/notesSlide15.xml><?xml version="1.0" encoding="utf-8"?>
+<p:notes xmlns:a="http://schemas.openxmlformats.org/drawingml/2006/main" xmlns:r="http://schemas.openxmlformats.org/officeDocument/2006/relationships" xmlns:p="http://schemas.openxmlformats.org/presentationml/2006/main">
+  <p:cSld>
+    <p:spTree>
+      <p:nvGrpSpPr>
+        <p:cNvPr id="1" name=""/>
+        <p:cNvGrpSpPr/>
+        <p:nvPr/>
+      </p:nvGrpSpPr>
+      <p:grpSpPr>
+        <a:xfrm>
+          <a:off x="0" y="0"/>
+          <a:ext cx="0" cy="0"/>
+          <a:chOff x="0" y="0"/>
+          <a:chExt cx="0" cy="0"/>
+        </a:xfrm>
+      </p:grpSpPr>
+      <p:sp>
+        <p:nvSpPr>
+          <p:cNvPr id="2" name="Slide Image Placeholder 1"/>
+          <p:cNvSpPr>
+            <a:spLocks noGrp="1" noRot="1" noChangeAspect="1"/>
+          </p:cNvSpPr>
+          <p:nvPr>
+            <p:ph type="sldImg"/>
+          </p:nvPr>
+        </p:nvSpPr>
+        <p:spPr/>
+      </p:sp>
+      <p:sp>
+        <p:nvSpPr>
+          <p:cNvPr id="3" name="Notes Placeholder 2"/>
+          <p:cNvSpPr>
+            <a:spLocks noGrp="1"/>
+          </p:cNvSpPr>
+          <p:nvPr>
+            <p:ph type="body" idx="1"/>
+          </p:nvPr>
+        </p:nvSpPr>
+        <p:spPr/>
+        <p:txBody>
+          <a:bodyPr/>
+          <a:lstStyle/>
+          <a:p>
+            <a:r>
+              <a:rPr lang="en-US" dirty="0"/>
+              <a:t>Point judges to the repo files if they ask for evidence.</a:t>
+            </a:r>
+            <a:endParaRPr lang="en-US" dirty="0"/>
+          </a:p>
+        </p:txBody>
+      </p:sp>
+      <p:sp>
+        <p:nvSpPr>
+          <p:cNvPr id="4" name="Slide Number Placeholder 3"/>
+          <p:cNvSpPr>
+            <a:spLocks noGrp="1"/>
+          </p:cNvSpPr>
+          <p:nvPr>
+            <p:ph type="sldNum" sz="quarter" idx="10"/>
+          </p:nvPr>
+        </p:nvSpPr>
+        <p:spPr/>
+        <p:txBody>
+          <a:bodyPr/>
+          <a:lstStyle/>
+          <a:p>
+            <a:fld id="{F7021451-1387-4CA6-816F-3879F97B5CBC}" type="slidenum">
+              <a:rPr lang="en-US"/>
+              <a:t>15</a:t>
+            </a:fld>
+            <a:endParaRPr lang="en-US"/>
+          </a:p>
+        </p:txBody>
+      </p:sp>
+    </p:spTree>
+    <p:extLst>
+      <p:ext uri="{BB962C8B-B14F-4D97-AF65-F5344CB8AC3E}">
+        <p14:creationId xmlns:p14="http://schemas.microsoft.com/office/powerpoint/2010/main" val="1024086991"/>
+      </p:ext>
+    </p:extLst>
+  </p:cSld>
+  <p:clrMapOvr>
+    <a:masterClrMapping/>
+  </p:clrMapOvr>
+</p:notes>
+</file>
+
 <file path=ppt/notesSlides/notesSlide2.xml><?xml version="1.0" encoding="utf-8"?>
 <p:notes xmlns:a="http://schemas.openxmlformats.org/drawingml/2006/main" xmlns:r="http://schemas.openxmlformats.org/officeDocument/2006/relationships" xmlns:p="http://schemas.openxmlformats.org/presentationml/2006/main">
   <p:cSld>
@@ -1049,10 +1138,10 @@
           <a:p>
             <a:r>
               <a:rPr lang="en-US" dirty="0"/>
-              <a:t>TIME 0:30–1:40 (70 s).
-SAY: "The 5-million-kilogram figure in the problem statement comes from The Ocean Cleanup's 2026 survey of Mumbai. An independent global model puts Malad Creek alone among the top 30 river mouths on Earth. The plastic reaches the sea through drains like these: about 186 outfalls, built for modest rain at low tide."
-LINE TO LAND: "In July 2026, BMC pulled 2,498.66 t of waste off seven beaches in 11 days. That is the sea handing back what the drains gave it."
-DON'T SAY the tonnage was measured. It is a survey estimate. If asked, the model (Meijer) and the survey disagree on exact tonnage; both put Mumbai among the largest urban sources.</a:t>
+              <a:t>TIME 0:25–1:25 (60 s).
+SAY: "The 5-million-kilogram figure in the problem statement is The Ocean Cleanup's 2026 estimate for the region. BMC itself describes the cycle: July rain washed refuse from drains into the sea, and high tides carried it back onto the beaches. Most beach litter is plastic. We target the film and sachets that nobody is paid to collect."
+LINE TO LAND: "We target the plastic nobody is paid to collect."
+DON'T SAY the tonnage was measured. It is a survey estimate. DON'T SAY "pickers never collect film"; the source says it is disregarded and low-value.</a:t>
             </a:r>
             <a:endParaRPr lang="en-US" dirty="0"/>
           </a:p>
@@ -1140,10 +1229,10 @@
           <a:p>
             <a:r>
               <a:rPr lang="en-US" dirty="0"/>
-              <a:t>TIME 1:40–2:30 (50 s).
-SAY: "Bottles have a price, so someone picks them up. Films and sachets don't, so they are what's left for the rain to wash into the nullahs."
-LINE TO LAND: "We target the plastic nobody is paid to collect."
-DON'T SAY "pickers never collect film". The source says companies disregard low-value plastics and only a small fraction of MLP is collected under EPR.</a:t>
+              <a:t>TIME 1:25–2:30 (65 s).
+SAY: "Here is the whole idea on one drawing. Today's boom sits square across the nullah. We would angle it, lead the catch into a bank-side pocket with one-way flaps, and put a hinged section in the middle that is meant to swing open before the boom backs water up. A camera watches the pocket; an ultrasonic sensor watches the water level. In the morning, the engineer gets a plan; after each clearance, a signed record."
+LINE TO LAND: "One operator decision changes: when the crew goes, and what proves what they removed."
+DON'T SAY the release "can't fail" or that the pocket "keeps everything". The opening head, delay, fouling and retention during release are exactly what we test.</a:t>
             </a:r>
             <a:endParaRPr lang="en-US" dirty="0"/>
           </a:p>
@@ -1231,10 +1320,10 @@
           <a:p>
             <a:r>
               <a:rPr lang="en-US" dirty="0"/>
-              <a:t>TIME 2:30–3:30 (60 s).
-SAY: "This is not an empty field. BMC is going from 9 to 23 booms at about a crore each, and The Ocean Cleanup is coming to Malad and Trombay — the two outlets in your problem statement. What nobody has is a way to know when a boom is about to fail, and whether the tonnage on the invoice was really caught."
-LINE TO LAND: "Two Interceptors cover two creeks. NullahNet is for the other booms."
-DON'T SAY anything about guilt in the Mithi case: it is a police investigation into alleged inflated quantities.</a:t>
+              <a:t>TIME 2:30–3:25 (55 s).
+SAY: "This is not an empty field. BMC has booms and a maintenance contract; The Ocean Cleanup is coming to Malad and Trombay; Plastic Fischer already runs booms and verifies kilograms. What we couldn't find in public is fill sensing or tide-timed clearance at BMC's booms. That's our hypothesis to test with BMC, not a claim that nobody does it."
+LINE TO LAND: "We build on the city's booms and their verification norms; we don't compete with them."
+DON'T SAY "the booms have no sensors" or "nobody does this". Say "we found no public evidence". DON'T SAY anything about guilt in the Mithi case.</a:t>
             </a:r>
             <a:endParaRPr lang="en-US" dirty="0"/>
           </a:p>
@@ -1322,10 +1411,10 @@
           <a:p>
             <a:r>
               <a:rPr lang="en-US" dirty="0"/>
-              <a:t>TIME 3:30–4:40 (70 s).
-SAY: "We built a twin of four real outfalls, driven by real rain, archived forecasts and fitted tides. Most of what escapes slips under the boom when the flow is fast, not over the top. That matches oil-spill boom practice: above about a third of a metre per second, booms leak."
-LINE TO LAND: "Booms don't mainly fail by filling up; they fail by being too square to the flow."
-DON'T SAY the twin "measured" anything. It computes with assumed curves; it ranks levers, it does not promise tonnes. The capture curve's midpoint is an ASSUMPTION based on oil-boom practice.</a:t>
+              <a:t>TIME 3:25–4:20 (55 s).
+SAY: "In our model, most plastic escapes by slipping under or through the boom, not by overflowing a full pocket. But that pattern comes from the capture curve we assumed, informed by oil-boom practice. It tells us what to test first: angle and retention."
+LINE TO LAND: "The twin tells us where to look; the tow tank must tell us whether it's true."
+DON'T SAY "booms fail because they're square to the flow" as a finding. It is a hypothesis built into the model.</a:t>
             </a:r>
             <a:endParaRPr lang="en-US" dirty="0"/>
           </a:p>
@@ -1413,10 +1502,10 @@
           <a:p>
             <a:r>
               <a:rPr lang="en-US" dirty="0"/>
-              <a:t>TIME 4:40–5:40 (60 s).
-SAY: "Five layers, all bolted onto what exists. Eyes on the pocket, a twin that knows the tide and tomorrow's rain, a dispatch plan, a hardware retrofit, and records nobody can quietly edit."
-LINE TO LAND: "No new civil works. We change when crews go, how booms sit, and how contractors are paid."
-DON'T SAY "our trap is novel". One-way floating traps exist; our claim is the retrofit plus the fail-open safety and the instrumentation, and only what the flume shows.</a:t>
+              <a:t>TIME 4:20–5:30 (70 s).
+SAY: "Same two crews, same hours, one model with many parameter settings. Our full policy lets less plastic escape than a simple 'clear the fullest boom' rule in 39 of 40 settings. Against a fixed roster, which we assumed rather than observed, the gain is small and could be zero. The comparison bundles three changes (ranking by kilograms, tide timing, forecasts), so we don't credit any one of them alone."
+LINE TO LAND: "In our model, a sensor without good timing can make things worse; the combination is what helps."
+DON'T SAY "tide timing saves this much" or "39 of 40 seasons". It's 39 of 40 parameter settings of one model, and the gain belongs to the whole policy.</a:t>
             </a:r>
             <a:endParaRPr lang="en-US" dirty="0"/>
           </a:p>
@@ -1504,10 +1593,10 @@
           <a:p>
             <a:r>
               <a:rPr lang="en-US" dirty="0"/>
-              <a:t>TIME 5:40–6:50 (70 s).
-SAY: "Same two crews, same hours. Timing work to the tide beats the obvious 'clear it when it looks full' rule in 39 of 40 simulated seasons. Against today's fixed schedule the gain is a couple of percent and could be zero."
-LINE TO LAND: "Sensors alone don't help; sensors plus tide-aware timing do. And dispatch is not our biggest lever — capture is."
-DON'T SAY "we cut plastic" without "in our simulation, against a sensor-threshold rule". Never quote absolute tonnes from the twin.</a:t>
+              <a:t>TIME 5:30–6:25 (55 s).
+SAY: "These are what-ifs, not evidence. The fail-open section barely changes capture in the model; it's there for flood safety, which we still have to measure. A one-way pocket matters only if it really holds its catch when the tide reverses, and that is the first thing our tow tank measures."
+LINE TO LAND: "We only claim what the tow tank shows."
+DON'T SAY the pocket "cuts escape" as a fact. Say "if it retains half, the model says −5.0%".</a:t>
             </a:r>
             <a:endParaRPr lang="en-US" dirty="0"/>
           </a:p>
@@ -1595,10 +1684,10 @@
           <a:p>
             <a:r>
               <a:rPr lang="en-US" dirty="0"/>
-              <a:t>TIME 6:50–7:50 (60 s).
-SAY: "The fuse is there so the boom is never the reason a street floods; in the twin it barely changes capture. The one-way pocket is the capture lever we must prove in the flume. The camera is instrumentation, not our novelty. The records system catches most inflated claims in synthetic tests, but at low fraud rates many flags are false, so a flag means a second look, not a penalty."
+              <a:t>TIME 6:25–7:25 (60 s).
+SAY: "The camera is an aid; when it can't see, we say so and fall back to the roster. The records system catches most inflated claims in synthetic tests, misses small ones, and its false flags depend on knowing the debris density, so a flag means a second look, never a penalty."
 LINE TO LAND: "We report our weak numbers as plainly as our strong ones."
-DON'T SAY "AI detects all plastic". Night, rain, glare and submerged film are real limits; fill from a range sensor is the primary reading.</a:t>
+DON'T SAY "AI detects all plastic" or "tamper-proof". Hashes make edits detectable; they cannot make inputs true.</a:t>
             </a:r>
             <a:endParaRPr lang="en-US" dirty="0"/>
           </a:p>
@@ -1686,10 +1775,10 @@
           <a:p>
             <a:r>
               <a:rPr lang="en-US" dirty="0"/>
-              <a:t>TIME 7:50–8:40 (50 s).
-SAY: "Every hardware line is priced from a real Indian retailer page, with the link and the date in our prototype plan. A sensor node costs less than one percent of a boom, and the boom's yearly upkeep is about a crore."
-LINE TO LAND: "If NullahNet makes even a sliver of that upkeep better targeted or better verified, it pays for itself."
-DON'T SAY a payback period as fact. It depends on the effect size, which the pilot must measure.</a:t>
+              <a:t>TIME 7:25–8:20 (55 s).
+SAY: "Every hardware line is priced from a real Indian retailer page, with link and date in the prototype plan. That's listed parts, not an installed cost; installation, anchoring and servicing come on top. Even so, a sensor node is under one percent of a boom's reported price."
+LINE TO LAND: "Small add-on, large existing asset."
+DON'T SAY it "pays for itself"; the effect size is unmeasured. DON'T divide the maintenance contract per boom; we don't have its asset list.</a:t>
             </a:r>
             <a:endParaRPr lang="en-US" dirty="0"/>
           </a:p>
@@ -2236,6 +2325,45 @@
 <file path=ppt/slides/slide14.xml><?xml version="1.0" encoding="utf-8"?>
 <p:sld xmlns:a="http://schemas.openxmlformats.org/drawingml/2006/main" xmlns:r="http://schemas.openxmlformats.org/officeDocument/2006/relationships" xmlns:p="http://schemas.openxmlformats.org/presentationml/2006/main">
   <p:cSld name="Slide 14">
+    <p:bg>
+      <p:bgPr>
+        <a:blipFill dpi="0" rotWithShape="1">
+          <a:blip r:embed="rId1">
+            <a:lum/>
+          </a:blip>
+          <a:srcRect/>
+          <a:stretch>
+            <a:fillRect/>
+          </a:stretch>
+        </a:blipFill>
+        <a:effectLst/>
+      </p:bgPr>
+    </p:bg>
+    <p:spTree>
+      <p:nvGrpSpPr>
+        <p:cNvPr id="1" name=""/>
+        <p:cNvGrpSpPr/>
+        <p:nvPr/>
+      </p:nvGrpSpPr>
+      <p:grpSpPr>
+        <a:xfrm>
+          <a:off x="0" y="0"/>
+          <a:ext cx="0" cy="0"/>
+          <a:chOff x="0" y="0"/>
+          <a:chExt cx="0" cy="0"/>
+        </a:xfrm>
+      </p:grpSpPr>
+    </p:spTree>
+  </p:cSld>
+  <p:clrMapOvr>
+    <a:masterClrMapping/>
+  </p:clrMapOvr>
+</p:sld>
+</file>
+
+<file path=ppt/slides/slide15.xml><?xml version="1.0" encoding="utf-8"?>
+<p:sld xmlns:a="http://schemas.openxmlformats.org/drawingml/2006/main" xmlns:r="http://schemas.openxmlformats.org/officeDocument/2006/relationships" xmlns:p="http://schemas.openxmlformats.org/presentationml/2006/main">
+  <p:cSld name="Slide 15">
     <p:bg>
       <p:bgPr>
         <a:blipFill dpi="0" rotWithShape="1">

</xml_diff>

<commit_message>
innovatex-t3-coastal-plastic: deck v3 after hostile review — ablations, entrainment floor/velocity split, exposure, boom-angle SENSITIVITY, hedged guarantees, sensing roles, layout fixes
</commit_message>
<xml_diff>
--- a/innovatex-t3-coastal-plastic/deliverables/zonal-deck.pptx
+++ b/innovatex-t3-coastal-plastic/deliverables/zonal-deck.pptx
@@ -1412,7 +1412,7 @@
             <a:r>
               <a:rPr lang="en-US" dirty="0"/>
               <a:t>TIME 3:25–4:20 (55 s).
-SAY: "In our model, most plastic escapes by slipping under or through the boom, not by overflowing a full pocket. But that pattern comes from the capture curve we assumed, informed by oil-boom practice. It tells us what to test first: angle and retention."
+SAY: "In our model, most plastic escapes by slipping under or through the boom, not by overflowing a full pocket. But half of that is a constant leak we assumed, and fast flow is rare. So the first thing to measure is a real boom's leak, then angle and retention."
 LINE TO LAND: "The twin tells us where to look; the tow tank must tell us whether it's true."
 DON'T SAY "booms fail because they're square to the flow" as a finding. It is a hypothesis built into the model.</a:t>
             </a:r>
@@ -1505,7 +1505,7 @@
               <a:t>TIME 4:20–5:30 (70 s).
 SAY: "Same two crews, same hours, one model with many parameter settings. Our full policy lets less plastic escape than a simple 'clear the fullest boom' rule in 39 of 40 settings. Against a fixed roster, which we assumed rather than observed, the gain is small and could be zero. The comparison bundles three changes (ranking by kilograms, tide timing, forecasts), so we don't credit any one of them alone."
 LINE TO LAND: "In our model, a sensor without good timing can make things worse; the combination is what helps."
-DON'T SAY "tide timing saves this much" or "39 of 40 seasons". It's 39 of 40 parameter settings of one model, and the gain belongs to the whole policy.</a:t>
+Decisions use only forecasts archived before the fact. DON'T SAY "tide timing saves this much" or call the settings "seasons". It's 39 of 40 parameter settings of one model, and the gain belongs to the whole policy; tide timing alone does not clear zero.</a:t>
             </a:r>
             <a:endParaRPr lang="en-US" dirty="0"/>
           </a:p>
@@ -1594,7 +1594,7 @@
             <a:r>
               <a:rPr lang="en-US" dirty="0"/>
               <a:t>TIME 5:30–6:25 (55 s).
-SAY: "These are what-ifs, not evidence. The fail-open section barely changes capture in the model; it's there for flood safety, which we still have to measure. A one-way pocket matters only if it really holds its catch when the tide reverses, and that is the first thing our tow tank measures."
+SAY: "These are what-ifs, not evidence. The fail-open section barely changes capture; it's there for flood safety, which we still have to measure. A pocket and an angled boom help in the model, but only because of curves we assumed. A 20-degree boom is about three times as long as the channel is wide, so it may not fit every nullah. The tow tank decides."
 LINE TO LAND: "We only claim what the tow tank shows."
 DON'T SAY the pocket "cuts escape" as a fact. Say "if it retains half, the model says −5.0%".</a:t>
             </a:r>

</xml_diff>

<commit_message>
innovatex-t3-coastal-plastic: re-render package on the leak-free tide refit (P2 vs P1 -5.2% [-15.9, -0.8], 39/40), fixed flux counter and like-for-like detector line; RESULTS.md fresh; check_docs 0
</commit_message>
<xml_diff>
--- a/innovatex-t3-coastal-plastic/deliverables/zonal-deck.pptx
+++ b/innovatex-t3-coastal-plastic/deliverables/zonal-deck.pptx
@@ -698,7 +698,7 @@
           <a:p>
             <a:r>
               <a:rPr lang="en-US" dirty="0"/>
-              <a:t>Use if asked "show us the software". Walk: map → a site → rain + tide → fill and escape (SIMULATED) → tomorrow's plan → ledger tab with signature check → tamper demo.</a:t>
+              <a:t>Use if asked "show us the software". Walk: morning brief → first dispatch → "Why?" (inputs, what the fill-threshold rule and the roster would do, simulation evidence) → Copy crew message → the site's rain, tide and fill chart → claims that need checking → Tamper demo → ‹ › to another replay day.</a:t>
             </a:r>
             <a:endParaRPr lang="en-US" dirty="0"/>
           </a:p>
@@ -1596,7 +1596,7 @@
               <a:t>TIME 5:30–6:25 (55 s).
 SAY: "These are what-ifs, not evidence. The fail-open section barely changes capture; it's there for flood safety, which we still have to measure. A pocket and an angled boom help in the model, but only because of curves we assumed. A 20-degree boom is about three times as long as the channel is wide, so it may not fit every nullah. The tow tank decides."
 LINE TO LAND: "We only claim what the tow tank shows."
-DON'T SAY the pocket "cuts escape" as a fact. Say "if it retains half, the model says −5.0%".</a:t>
+DON'T SAY the pocket "cuts escape" as a fact. Say "if it retains half, the model says −5.1%".</a:t>
             </a:r>
             <a:endParaRPr lang="en-US" dirty="0"/>
           </a:p>

</xml_diff>